<commit_message>
Changes in the mechanical block diagram
</commit_message>
<xml_diff>
--- a/docs/Diagrams.pptx
+++ b/docs/Diagrams.pptx
@@ -105,6 +105,11 @@
       </a:defRPr>
     </a:lvl9pPr>
   </p:defaultTextStyle>
+  <p:extLst>
+    <p:ext uri="{EFAFB233-063F-42B5-8137-9DF3F51BA10A}">
+      <p15:sldGuideLst xmlns:p15="http://schemas.microsoft.com/office/powerpoint/2012/main"/>
+    </p:ext>
+  </p:extLst>
 </p:presentation>
 </file>
 
@@ -255,7 +260,7 @@
           <a:p>
             <a:fld id="{B9B65B95-89D5-440B-8A50-A9C8934CB761}" type="datetimeFigureOut">
               <a:rPr lang="en-US" smtClean="0"/>
-              <a:t>7/27/2026</a:t>
+              <a:t>8/11/2026</a:t>
             </a:fld>
             <a:endParaRPr lang="en-US"/>
           </a:p>
@@ -453,7 +458,7 @@
           <a:p>
             <a:fld id="{B9B65B95-89D5-440B-8A50-A9C8934CB761}" type="datetimeFigureOut">
               <a:rPr lang="en-US" smtClean="0"/>
-              <a:t>7/27/2026</a:t>
+              <a:t>8/11/2026</a:t>
             </a:fld>
             <a:endParaRPr lang="en-US"/>
           </a:p>
@@ -661,7 +666,7 @@
           <a:p>
             <a:fld id="{B9B65B95-89D5-440B-8A50-A9C8934CB761}" type="datetimeFigureOut">
               <a:rPr lang="en-US" smtClean="0"/>
-              <a:t>7/27/2026</a:t>
+              <a:t>8/11/2026</a:t>
             </a:fld>
             <a:endParaRPr lang="en-US"/>
           </a:p>
@@ -859,7 +864,7 @@
           <a:p>
             <a:fld id="{B9B65B95-89D5-440B-8A50-A9C8934CB761}" type="datetimeFigureOut">
               <a:rPr lang="en-US" smtClean="0"/>
-              <a:t>7/27/2026</a:t>
+              <a:t>8/11/2026</a:t>
             </a:fld>
             <a:endParaRPr lang="en-US"/>
           </a:p>
@@ -1134,7 +1139,7 @@
           <a:p>
             <a:fld id="{B9B65B95-89D5-440B-8A50-A9C8934CB761}" type="datetimeFigureOut">
               <a:rPr lang="en-US" smtClean="0"/>
-              <a:t>7/27/2026</a:t>
+              <a:t>8/11/2026</a:t>
             </a:fld>
             <a:endParaRPr lang="en-US"/>
           </a:p>
@@ -1399,7 +1404,7 @@
           <a:p>
             <a:fld id="{B9B65B95-89D5-440B-8A50-A9C8934CB761}" type="datetimeFigureOut">
               <a:rPr lang="en-US" smtClean="0"/>
-              <a:t>7/27/2026</a:t>
+              <a:t>8/11/2026</a:t>
             </a:fld>
             <a:endParaRPr lang="en-US"/>
           </a:p>
@@ -1811,7 +1816,7 @@
           <a:p>
             <a:fld id="{B9B65B95-89D5-440B-8A50-A9C8934CB761}" type="datetimeFigureOut">
               <a:rPr lang="en-US" smtClean="0"/>
-              <a:t>7/27/2026</a:t>
+              <a:t>8/11/2026</a:t>
             </a:fld>
             <a:endParaRPr lang="en-US"/>
           </a:p>
@@ -1952,7 +1957,7 @@
           <a:p>
             <a:fld id="{B9B65B95-89D5-440B-8A50-A9C8934CB761}" type="datetimeFigureOut">
               <a:rPr lang="en-US" smtClean="0"/>
-              <a:t>7/27/2026</a:t>
+              <a:t>8/11/2026</a:t>
             </a:fld>
             <a:endParaRPr lang="en-US"/>
           </a:p>
@@ -2065,7 +2070,7 @@
           <a:p>
             <a:fld id="{B9B65B95-89D5-440B-8A50-A9C8934CB761}" type="datetimeFigureOut">
               <a:rPr lang="en-US" smtClean="0"/>
-              <a:t>7/27/2026</a:t>
+              <a:t>8/11/2026</a:t>
             </a:fld>
             <a:endParaRPr lang="en-US"/>
           </a:p>
@@ -2376,7 +2381,7 @@
           <a:p>
             <a:fld id="{B9B65B95-89D5-440B-8A50-A9C8934CB761}" type="datetimeFigureOut">
               <a:rPr lang="en-US" smtClean="0"/>
-              <a:t>7/27/2026</a:t>
+              <a:t>8/11/2026</a:t>
             </a:fld>
             <a:endParaRPr lang="en-US"/>
           </a:p>
@@ -2664,7 +2669,7 @@
           <a:p>
             <a:fld id="{B9B65B95-89D5-440B-8A50-A9C8934CB761}" type="datetimeFigureOut">
               <a:rPr lang="en-US" smtClean="0"/>
-              <a:t>7/27/2026</a:t>
+              <a:t>8/11/2026</a:t>
             </a:fld>
             <a:endParaRPr lang="en-US"/>
           </a:p>
@@ -2905,7 +2910,7 @@
           <a:p>
             <a:fld id="{B9B65B95-89D5-440B-8A50-A9C8934CB761}" type="datetimeFigureOut">
               <a:rPr lang="en-US" smtClean="0"/>
-              <a:t>7/27/2026</a:t>
+              <a:t>8/11/2026</a:t>
             </a:fld>
             <a:endParaRPr lang="en-US"/>
           </a:p>
@@ -4931,7 +4936,7 @@
           </p:nvSpPr>
           <p:spPr>
             <a:xfrm>
-              <a:off x="4640179" y="1937085"/>
+              <a:off x="4640179" y="2418661"/>
               <a:ext cx="2911642" cy="1251284"/>
             </a:xfrm>
             <a:prstGeom prst="rect">
@@ -4980,7 +4985,7 @@
           </p:nvSpPr>
           <p:spPr>
             <a:xfrm>
-              <a:off x="5478379" y="3392905"/>
+              <a:off x="5539040" y="3883256"/>
               <a:ext cx="1235242" cy="553453"/>
             </a:xfrm>
             <a:prstGeom prst="rect">
@@ -5029,7 +5034,7 @@
           </p:nvSpPr>
           <p:spPr>
             <a:xfrm>
-              <a:off x="3551321" y="4150894"/>
+              <a:off x="3551321" y="5519612"/>
               <a:ext cx="5089358" cy="1383632"/>
             </a:xfrm>
             <a:prstGeom prst="rect">
@@ -5078,8 +5083,8 @@
           </p:nvSpPr>
           <p:spPr>
             <a:xfrm>
-              <a:off x="3564355" y="5739061"/>
-              <a:ext cx="2151647" cy="1263315"/>
+              <a:off x="3551321" y="3871285"/>
+              <a:ext cx="1745947" cy="1495494"/>
             </a:xfrm>
             <a:prstGeom prst="rect">
               <a:avLst/>
@@ -5127,8 +5132,8 @@
           </p:nvSpPr>
           <p:spPr>
             <a:xfrm>
-              <a:off x="5894471" y="5739061"/>
-              <a:ext cx="2746208" cy="1263315"/>
+              <a:off x="4640179" y="1078929"/>
+              <a:ext cx="2911642" cy="1263315"/>
             </a:xfrm>
             <a:prstGeom prst="rect">
               <a:avLst/>
@@ -5164,55 +5169,6 @@
         </p:sp>
         <p:sp>
           <p:nvSpPr>
-            <p:cNvPr id="20" name="Rectangle 19">
-              <a:extLst>
-                <a:ext uri="{FF2B5EF4-FFF2-40B4-BE49-F238E27FC236}">
-                  <a16:creationId xmlns:a16="http://schemas.microsoft.com/office/drawing/2014/main" id="{C5A066F7-82B0-63C5-F298-3D9FE28EE123}"/>
-                </a:ext>
-              </a:extLst>
-            </p:cNvPr>
-            <p:cNvSpPr/>
-            <p:nvPr/>
-          </p:nvSpPr>
-          <p:spPr>
-            <a:xfrm rot="5400000">
-              <a:off x="7618246" y="2165936"/>
-              <a:ext cx="1251284" cy="793582"/>
-            </a:xfrm>
-            <a:prstGeom prst="rect">
-              <a:avLst/>
-            </a:prstGeom>
-          </p:spPr>
-          <p:style>
-            <a:lnRef idx="2">
-              <a:schemeClr val="accent1">
-                <a:shade val="15000"/>
-              </a:schemeClr>
-            </a:lnRef>
-            <a:fillRef idx="1">
-              <a:schemeClr val="accent1"/>
-            </a:fillRef>
-            <a:effectRef idx="0">
-              <a:schemeClr val="accent1"/>
-            </a:effectRef>
-            <a:fontRef idx="minor">
-              <a:schemeClr val="lt1"/>
-            </a:fontRef>
-          </p:style>
-          <p:txBody>
-            <a:bodyPr rtlCol="0" anchor="ctr"/>
-            <a:lstStyle/>
-            <a:p>
-              <a:pPr algn="ctr"/>
-              <a:r>
-                <a:rPr lang="en-US" dirty="0"/>
-                <a:t>Holder for Antenna</a:t>
-              </a:r>
-            </a:p>
-          </p:txBody>
-        </p:sp>
-        <p:sp>
-          <p:nvSpPr>
             <p:cNvPr id="22" name="Rectangle 21">
               <a:extLst>
                 <a:ext uri="{FF2B5EF4-FFF2-40B4-BE49-F238E27FC236}">
@@ -5225,8 +5181,8 @@
           </p:nvSpPr>
           <p:spPr>
             <a:xfrm>
-              <a:off x="3388894" y="938967"/>
-              <a:ext cx="1251284" cy="793582"/>
+              <a:off x="7128710" y="3871285"/>
+              <a:ext cx="1251284" cy="1495494"/>
             </a:xfrm>
             <a:prstGeom prst="rect">
               <a:avLst/>
@@ -5274,7 +5230,7 @@
           </p:nvSpPr>
           <p:spPr>
             <a:xfrm>
-              <a:off x="3388894" y="-47118"/>
+              <a:off x="5539040" y="4575384"/>
               <a:ext cx="1251284" cy="793582"/>
             </a:xfrm>
             <a:prstGeom prst="rect">
@@ -5323,8 +5279,8 @@
           </p:nvSpPr>
           <p:spPr>
             <a:xfrm>
-              <a:off x="4939969" y="-47118"/>
-              <a:ext cx="3700710" cy="1779667"/>
+              <a:off x="4640179" y="-156655"/>
+              <a:ext cx="2911642" cy="1159168"/>
             </a:xfrm>
             <a:prstGeom prst="rect">
               <a:avLst/>

</xml_diff>